<commit_message>
pptx edit (moved to onedrive)
</commit_message>
<xml_diff>
--- a/DS/general_exercise/プレゼンテーション.pptx
+++ b/DS/general_exercise/プレゼンテーション.pptx
@@ -4105,10 +4105,9 @@
           <a:lstStyle/>
           <a:p>
             <a:r>
-              <a:rPr kumimoji="1" lang="en-US" altLang="ja-JP" dirty="0" err="1"/>
-              <a:t>aaaaaa</a:t>
-            </a:r>
-            <a:endParaRPr kumimoji="1" lang="ja-JP" altLang="en-US"/>
+              <a:rPr kumimoji="1" lang="ja-JP" altLang="en-US"/>
+              <a:t>人口密度</a:t>
+            </a:r>
           </a:p>
         </p:txBody>
       </p:sp>

</xml_diff>